<commit_message>
fix: sanitize budget review baseline geometry XML
</commit_message>
<xml_diff>
--- a/examples/budget_review_v2.pptx
+++ b/examples/budget_review_v2.pptx
@@ -647,14 +647,6 @@
             <a:off x="360000" y="4680000"/>
             <a:ext cx="1440000" cy="1440000"/>
           </a:xfrm>
-          <a:solidFill>
-            <a:srgbClr val="8BC94A">
-              <a:alpha val="18000"/>
-            </a:srgbClr>
-          </a:solidFill>
-          <a:ln>
-            <a:noFill/>
-          </a:ln>
           <a:custGeom>
             <a:avLst/>
             <a:gdLst/>
@@ -679,6 +671,14 @@
               </a:path>
             </a:pathLst>
           </a:custGeom>
+          <a:solidFill>
+            <a:srgbClr val="8BC94A">
+              <a:alpha val="18000"/>
+            </a:srgbClr>
+          </a:solidFill>
+          <a:ln>
+            <a:noFill/>
+          </a:ln>
         </p:spPr>
         <p:txBody>
           <a:bodyPr/>
@@ -798,7 +798,7 @@
         <p:spPr>
           <a:xfrm>
             <a:off x="432000" y="792000"/>
-            <a:ext cx="2520000" cy="108000"/>
+            <a:ext cx="2520000" cy="234000"/>
           </a:xfrm>
           <a:prstGeom prst="rect">
             <a:avLst/>
@@ -1170,14 +1170,6 @@
             <a:off x="9000000" y="1440000"/>
             <a:ext cx="1800000" cy="1800000"/>
           </a:xfrm>
-          <a:solidFill>
-            <a:srgbClr val="C9A84C">
-              <a:alpha val="20000"/>
-            </a:srgbClr>
-          </a:solidFill>
-          <a:ln>
-            <a:noFill/>
-          </a:ln>
           <a:custGeom>
             <a:avLst/>
             <a:gdLst/>
@@ -1202,6 +1194,14 @@
               </a:path>
             </a:pathLst>
           </a:custGeom>
+          <a:solidFill>
+            <a:srgbClr val="C9A84C">
+              <a:alpha val="20000"/>
+            </a:srgbClr>
+          </a:solidFill>
+          <a:ln>
+            <a:noFill/>
+          </a:ln>
         </p:spPr>
         <p:txBody>
           <a:bodyPr/>
@@ -1531,14 +1531,6 @@
             <a:off x="360000" y="5760000"/>
             <a:ext cx="1080000" cy="1080000"/>
           </a:xfrm>
-          <a:solidFill>
-            <a:srgbClr val="8BC94A">
-              <a:alpha val="12000"/>
-            </a:srgbClr>
-          </a:solidFill>
-          <a:ln>
-            <a:noFill/>
-          </a:ln>
           <a:custGeom>
             <a:avLst/>
             <a:gdLst/>
@@ -1563,6 +1555,14 @@
               </a:path>
             </a:pathLst>
           </a:custGeom>
+          <a:solidFill>
+            <a:srgbClr val="8BC94A">
+              <a:alpha val="12000"/>
+            </a:srgbClr>
+          </a:solidFill>
+          <a:ln>
+            <a:noFill/>
+          </a:ln>
         </p:spPr>
         <p:txBody>
           <a:bodyPr/>
@@ -1682,7 +1682,7 @@
         <p:spPr>
           <a:xfrm>
             <a:off x="432000" y="360000"/>
-            <a:ext cx="1800000" cy="108000"/>
+            <a:ext cx="1800000" cy="234000"/>
           </a:xfrm>
           <a:prstGeom prst="rect">
             <a:avLst/>
@@ -1964,12 +1964,6 @@
             <a:off x="576000" y="4014000"/>
             <a:ext cx="540000" cy="540000"/>
           </a:xfrm>
-          <a:noFill/>
-          <a:ln w="6">
-            <a:solidFill>
-              <a:srgbClr val="5A9E48"/>
-            </a:solidFill>
-          </a:ln>
           <a:custGeom>
             <a:avLst/>
             <a:gdLst/>
@@ -1990,6 +1984,12 @@
               </a:path>
             </a:pathLst>
           </a:custGeom>
+          <a:noFill/>
+          <a:ln w="6">
+            <a:solidFill>
+              <a:srgbClr val="5A9E48"/>
+            </a:solidFill>
+          </a:ln>
         </p:spPr>
         <p:txBody>
           <a:bodyPr/>
@@ -2011,7 +2011,7 @@
         <p:spPr>
           <a:xfrm>
             <a:off x="1296000" y="3960000"/>
-            <a:ext cx="1728000" cy="540000"/>
+            <a:ext cx="1728000" cy="594000"/>
           </a:xfrm>
           <a:prstGeom prst="rect">
             <a:avLst/>
@@ -2221,12 +2221,6 @@
             <a:off x="3420000" y="4014000"/>
             <a:ext cx="540000" cy="540000"/>
           </a:xfrm>
-          <a:noFill/>
-          <a:ln w="6">
-            <a:solidFill>
-              <a:srgbClr val="5A9E48"/>
-            </a:solidFill>
-          </a:ln>
           <a:custGeom>
             <a:avLst/>
             <a:gdLst/>
@@ -2247,6 +2241,12 @@
               </a:path>
             </a:pathLst>
           </a:custGeom>
+          <a:noFill/>
+          <a:ln w="6">
+            <a:solidFill>
+              <a:srgbClr val="5A9E48"/>
+            </a:solidFill>
+          </a:ln>
         </p:spPr>
         <p:txBody>
           <a:bodyPr/>
@@ -2440,7 +2440,7 @@
         <p:spPr>
           <a:xfrm>
             <a:off x="6264000" y="3348000"/>
-            <a:ext cx="2448000" cy="540000"/>
+            <a:ext cx="2448000" cy="576000"/>
           </a:xfrm>
           <a:prstGeom prst="rect">
             <a:avLst/>
@@ -2478,12 +2478,6 @@
             <a:off x="6264000" y="4014000"/>
             <a:ext cx="540000" cy="540000"/>
           </a:xfrm>
-          <a:noFill/>
-          <a:ln w="6">
-            <a:solidFill>
-              <a:srgbClr val="5A9E48"/>
-            </a:solidFill>
-          </a:ln>
           <a:custGeom>
             <a:avLst/>
             <a:gdLst/>
@@ -2504,6 +2498,12 @@
               </a:path>
             </a:pathLst>
           </a:custGeom>
+          <a:noFill/>
+          <a:ln w="6">
+            <a:solidFill>
+              <a:srgbClr val="5A9E48"/>
+            </a:solidFill>
+          </a:ln>
         </p:spPr>
         <p:txBody>
           <a:bodyPr/>
@@ -2735,12 +2735,6 @@
             <a:off x="9108000" y="4014000"/>
             <a:ext cx="540000" cy="540000"/>
           </a:xfrm>
-          <a:noFill/>
-          <a:ln w="6">
-            <a:solidFill>
-              <a:srgbClr val="5A9E48"/>
-            </a:solidFill>
-          </a:ln>
           <a:custGeom>
             <a:avLst/>
             <a:gdLst/>
@@ -2761,6 +2755,12 @@
               </a:path>
             </a:pathLst>
           </a:custGeom>
+          <a:noFill/>
+          <a:ln w="6">
+            <a:solidFill>
+              <a:srgbClr val="5A9E48"/>
+            </a:solidFill>
+          </a:ln>
         </p:spPr>
         <p:txBody>
           <a:bodyPr/>
@@ -2992,14 +2992,6 @@
             <a:off x="11160000" y="5400000"/>
             <a:ext cx="1440000" cy="1440000"/>
           </a:xfrm>
-          <a:solidFill>
-            <a:srgbClr val="8BC94A">
-              <a:alpha val="12000"/>
-            </a:srgbClr>
-          </a:solidFill>
-          <a:ln>
-            <a:noFill/>
-          </a:ln>
           <a:custGeom>
             <a:avLst/>
             <a:gdLst/>
@@ -3024,6 +3016,14 @@
               </a:path>
             </a:pathLst>
           </a:custGeom>
+          <a:solidFill>
+            <a:srgbClr val="8BC94A">
+              <a:alpha val="12000"/>
+            </a:srgbClr>
+          </a:solidFill>
+          <a:ln>
+            <a:noFill/>
+          </a:ln>
         </p:spPr>
         <p:txBody>
           <a:bodyPr/>
@@ -3143,7 +3143,7 @@
         <p:spPr>
           <a:xfrm>
             <a:off x="432000" y="360000"/>
-            <a:ext cx="2880000" cy="108000"/>
+            <a:ext cx="2880000" cy="234000"/>
           </a:xfrm>
           <a:prstGeom prst="rect">
             <a:avLst/>
@@ -3289,12 +3289,6 @@
             <a:off x="432000" y="4446000"/>
             <a:ext cx="540000" cy="540000"/>
           </a:xfrm>
-          <a:noFill/>
-          <a:ln w="6">
-            <a:solidFill>
-              <a:srgbClr val="C9A84C"/>
-            </a:solidFill>
-          </a:ln>
           <a:custGeom>
             <a:avLst/>
             <a:gdLst/>
@@ -3342,6 +3336,12 @@
               </a:path>
             </a:pathLst>
           </a:custGeom>
+          <a:noFill/>
+          <a:ln w="6">
+            <a:solidFill>
+              <a:srgbClr val="C9A84C"/>
+            </a:solidFill>
+          </a:ln>
         </p:spPr>
         <p:txBody>
           <a:bodyPr/>
@@ -3473,12 +3473,6 @@
             <a:off x="4320000" y="4446000"/>
             <a:ext cx="540000" cy="540000"/>
           </a:xfrm>
-          <a:noFill/>
-          <a:ln w="6">
-            <a:solidFill>
-              <a:srgbClr val="8BC94A"/>
-            </a:solidFill>
-          </a:ln>
           <a:custGeom>
             <a:avLst/>
             <a:gdLst/>
@@ -3505,6 +3499,12 @@
               </a:path>
             </a:pathLst>
           </a:custGeom>
+          <a:noFill/>
+          <a:ln w="6">
+            <a:solidFill>
+              <a:srgbClr val="8BC94A"/>
+            </a:solidFill>
+          </a:ln>
         </p:spPr>
         <p:txBody>
           <a:bodyPr/>
@@ -3636,12 +3636,6 @@
             <a:off x="7920000" y="4446000"/>
             <a:ext cx="540000" cy="540000"/>
           </a:xfrm>
-          <a:noFill/>
-          <a:ln w="6">
-            <a:solidFill>
-              <a:srgbClr val="6A6458"/>
-            </a:solidFill>
-          </a:ln>
           <a:custGeom>
             <a:avLst/>
             <a:gdLst/>
@@ -3675,6 +3669,12 @@
               </a:path>
             </a:pathLst>
           </a:custGeom>
+          <a:noFill/>
+          <a:ln w="6">
+            <a:solidFill>
+              <a:srgbClr val="6A6458"/>
+            </a:solidFill>
+          </a:ln>
         </p:spPr>
         <p:txBody>
           <a:bodyPr/>
@@ -3970,14 +3970,6 @@
             <a:off x="8496000" y="5400000"/>
             <a:ext cx="1080000" cy="1080000"/>
           </a:xfrm>
-          <a:solidFill>
-            <a:srgbClr val="8BC94A">
-              <a:alpha val="12000"/>
-            </a:srgbClr>
-          </a:solidFill>
-          <a:ln>
-            <a:noFill/>
-          </a:ln>
           <a:custGeom>
             <a:avLst/>
             <a:gdLst/>
@@ -4002,6 +3994,14 @@
               </a:path>
             </a:pathLst>
           </a:custGeom>
+          <a:solidFill>
+            <a:srgbClr val="8BC94A">
+              <a:alpha val="12000"/>
+            </a:srgbClr>
+          </a:solidFill>
+          <a:ln>
+            <a:noFill/>
+          </a:ln>
         </p:spPr>
         <p:txBody>
           <a:bodyPr/>
@@ -4087,7 +4087,7 @@
         <p:spPr>
           <a:xfrm>
             <a:off x="432000" y="360000"/>
-            <a:ext cx="3240000" cy="108000"/>
+            <a:ext cx="3240000" cy="234000"/>
           </a:xfrm>
           <a:prstGeom prst="rect">
             <a:avLst/>
@@ -4653,14 +4653,6 @@
             <a:off x="1440000" y="5400000"/>
             <a:ext cx="1440000" cy="1440000"/>
           </a:xfrm>
-          <a:solidFill>
-            <a:srgbClr val="C9A84C">
-              <a:alpha val="15000"/>
-            </a:srgbClr>
-          </a:solidFill>
-          <a:ln>
-            <a:noFill/>
-          </a:ln>
           <a:custGeom>
             <a:avLst/>
             <a:gdLst/>
@@ -4685,6 +4677,14 @@
               </a:path>
             </a:pathLst>
           </a:custGeom>
+          <a:solidFill>
+            <a:srgbClr val="C9A84C">
+              <a:alpha val="15000"/>
+            </a:srgbClr>
+          </a:solidFill>
+          <a:ln>
+            <a:noFill/>
+          </a:ln>
         </p:spPr>
         <p:txBody>
           <a:bodyPr/>
@@ -4770,7 +4770,7 @@
         <p:spPr>
           <a:xfrm>
             <a:off x="432000" y="360000"/>
-            <a:ext cx="3240000" cy="108000"/>
+            <a:ext cx="3240000" cy="234000"/>
           </a:xfrm>
           <a:prstGeom prst="rect">
             <a:avLst/>
@@ -5100,14 +5100,6 @@
             <a:off x="11520000" y="5400000"/>
             <a:ext cx="1080000" cy="1080000"/>
           </a:xfrm>
-          <a:solidFill>
-            <a:srgbClr val="8BC94A">
-              <a:alpha val="15000"/>
-            </a:srgbClr>
-          </a:solidFill>
-          <a:ln>
-            <a:noFill/>
-          </a:ln>
           <a:custGeom>
             <a:avLst/>
             <a:gdLst/>
@@ -5132,6 +5124,14 @@
               </a:path>
             </a:pathLst>
           </a:custGeom>
+          <a:solidFill>
+            <a:srgbClr val="8BC94A">
+              <a:alpha val="15000"/>
+            </a:srgbClr>
+          </a:solidFill>
+          <a:ln>
+            <a:noFill/>
+          </a:ln>
         </p:spPr>
         <p:txBody>
           <a:bodyPr/>
@@ -5219,7 +5219,7 @@
         <p:spPr>
           <a:xfrm>
             <a:off x="432000" y="360000"/>
-            <a:ext cx="3240000" cy="108000"/>
+            <a:ext cx="3240000" cy="234000"/>
           </a:xfrm>
           <a:prstGeom prst="rect">
             <a:avLst/>
@@ -5395,12 +5395,6 @@
             <a:off x="648000" y="2592000"/>
             <a:ext cx="720000" cy="720000"/>
           </a:xfrm>
-          <a:noFill/>
-          <a:ln w="7">
-            <a:solidFill>
-              <a:srgbClr val="C9A84C"/>
-            </a:solidFill>
-          </a:ln>
           <a:custGeom>
             <a:avLst/>
             <a:gdLst/>
@@ -5427,6 +5421,12 @@
               </a:path>
             </a:pathLst>
           </a:custGeom>
+          <a:noFill/>
+          <a:ln w="7">
+            <a:solidFill>
+              <a:srgbClr val="C9A84C"/>
+            </a:solidFill>
+          </a:ln>
         </p:spPr>
         <p:txBody>
           <a:bodyPr/>
@@ -5588,12 +5588,6 @@
             <a:off x="4572000" y="2592000"/>
             <a:ext cx="720000" cy="720000"/>
           </a:xfrm>
-          <a:noFill/>
-          <a:ln w="7">
-            <a:solidFill>
-              <a:srgbClr val="8BC94A"/>
-            </a:solidFill>
-          </a:ln>
           <a:custGeom>
             <a:avLst/>
             <a:gdLst/>
@@ -5636,6 +5630,12 @@
               </a:path>
             </a:pathLst>
           </a:custGeom>
+          <a:noFill/>
+          <a:ln w="7">
+            <a:solidFill>
+              <a:srgbClr val="8BC94A"/>
+            </a:solidFill>
+          </a:ln>
         </p:spPr>
         <p:txBody>
           <a:bodyPr/>
@@ -5797,12 +5797,6 @@
             <a:off x="8496000" y="2592000"/>
             <a:ext cx="720000" cy="720000"/>
           </a:xfrm>
-          <a:noFill/>
-          <a:ln w="7">
-            <a:solidFill>
-              <a:srgbClr val="6A6458"/>
-            </a:solidFill>
-          </a:ln>
           <a:custGeom>
             <a:avLst/>
             <a:gdLst/>
@@ -5836,6 +5830,12 @@
               </a:path>
             </a:pathLst>
           </a:custGeom>
+          <a:noFill/>
+          <a:ln w="7">
+            <a:solidFill>
+              <a:srgbClr val="6A6458"/>
+            </a:solidFill>
+          </a:ln>
         </p:spPr>
         <p:txBody>
           <a:bodyPr/>
@@ -6099,14 +6099,6 @@
             <a:off x="720000" y="3060000"/>
             <a:ext cx="1440000" cy="1440000"/>
           </a:xfrm>
-          <a:solidFill>
-            <a:srgbClr val="C9A84C">
-              <a:alpha val="20000"/>
-            </a:srgbClr>
-          </a:solidFill>
-          <a:ln>
-            <a:noFill/>
-          </a:ln>
           <a:custGeom>
             <a:avLst/>
             <a:gdLst/>
@@ -6131,6 +6123,14 @@
               </a:path>
             </a:pathLst>
           </a:custGeom>
+          <a:solidFill>
+            <a:srgbClr val="C9A84C">
+              <a:alpha val="20000"/>
+            </a:srgbClr>
+          </a:solidFill>
+          <a:ln>
+            <a:noFill/>
+          </a:ln>
         </p:spPr>
         <p:txBody>
           <a:bodyPr/>
@@ -6218,7 +6218,7 @@
         <p:spPr>
           <a:xfrm>
             <a:off x="432000" y="360000"/>
-            <a:ext cx="1800000" cy="108000"/>
+            <a:ext cx="1800000" cy="234000"/>
           </a:xfrm>
           <a:prstGeom prst="rect">
             <a:avLst/>
@@ -6394,12 +6394,6 @@
             <a:off x="792000" y="2664000"/>
             <a:ext cx="540000" cy="540000"/>
           </a:xfrm>
-          <a:noFill/>
-          <a:ln w="7">
-            <a:solidFill>
-              <a:srgbClr val="C9A84C"/>
-            </a:solidFill>
-          </a:ln>
           <a:custGeom>
             <a:avLst/>
             <a:gdLst/>
@@ -6420,6 +6414,12 @@
               </a:path>
             </a:pathLst>
           </a:custGeom>
+          <a:noFill/>
+          <a:ln w="7">
+            <a:solidFill>
+              <a:srgbClr val="C9A84C"/>
+            </a:solidFill>
+          </a:ln>
         </p:spPr>
         <p:txBody>
           <a:bodyPr/>
@@ -6479,12 +6479,6 @@
             <a:off x="1512000" y="3114000"/>
             <a:ext cx="540000" cy="540000"/>
           </a:xfrm>
-          <a:noFill/>
-          <a:ln w="6">
-            <a:solidFill>
-              <a:srgbClr val="C9A84C"/>
-            </a:solidFill>
-          </a:ln>
           <a:custGeom>
             <a:avLst/>
             <a:gdLst/>
@@ -6509,6 +6503,12 @@
               </a:path>
             </a:pathLst>
           </a:custGeom>
+          <a:noFill/>
+          <a:ln w="6">
+            <a:solidFill>
+              <a:srgbClr val="C9A84C"/>
+            </a:solidFill>
+          </a:ln>
         </p:spPr>
         <p:txBody>
           <a:bodyPr/>
@@ -6704,12 +6704,6 @@
             <a:off x="792000" y="4104000"/>
             <a:ext cx="540000" cy="540000"/>
           </a:xfrm>
-          <a:noFill/>
-          <a:ln w="7">
-            <a:solidFill>
-              <a:srgbClr val="8BC94A"/>
-            </a:solidFill>
-          </a:ln>
           <a:custGeom>
             <a:avLst/>
             <a:gdLst/>
@@ -6730,6 +6724,12 @@
               </a:path>
             </a:pathLst>
           </a:custGeom>
+          <a:noFill/>
+          <a:ln w="7">
+            <a:solidFill>
+              <a:srgbClr val="8BC94A"/>
+            </a:solidFill>
+          </a:ln>
         </p:spPr>
         <p:txBody>
           <a:bodyPr/>
@@ -6789,12 +6789,6 @@
             <a:off x="1512000" y="4554000"/>
             <a:ext cx="540000" cy="540000"/>
           </a:xfrm>
-          <a:noFill/>
-          <a:ln w="6">
-            <a:solidFill>
-              <a:srgbClr val="8BC94A"/>
-            </a:solidFill>
-          </a:ln>
           <a:custGeom>
             <a:avLst/>
             <a:gdLst/>
@@ -6819,6 +6813,12 @@
               </a:path>
             </a:pathLst>
           </a:custGeom>
+          <a:noFill/>
+          <a:ln w="6">
+            <a:solidFill>
+              <a:srgbClr val="8BC94A"/>
+            </a:solidFill>
+          </a:ln>
         </p:spPr>
         <p:txBody>
           <a:bodyPr/>
@@ -7014,12 +7014,6 @@
             <a:off x="792000" y="5544000"/>
             <a:ext cx="540000" cy="540000"/>
           </a:xfrm>
-          <a:noFill/>
-          <a:ln w="7">
-            <a:solidFill>
-              <a:srgbClr val="6A6458"/>
-            </a:solidFill>
-          </a:ln>
           <a:custGeom>
             <a:avLst/>
             <a:gdLst/>
@@ -7040,6 +7034,12 @@
               </a:path>
             </a:pathLst>
           </a:custGeom>
+          <a:noFill/>
+          <a:ln w="7">
+            <a:solidFill>
+              <a:srgbClr val="6A6458"/>
+            </a:solidFill>
+          </a:ln>
         </p:spPr>
         <p:txBody>
           <a:bodyPr/>
@@ -7099,12 +7099,6 @@
             <a:off x="1512000" y="5994000"/>
             <a:ext cx="540000" cy="540000"/>
           </a:xfrm>
-          <a:noFill/>
-          <a:ln w="6">
-            <a:solidFill>
-              <a:srgbClr val="6A6458"/>
-            </a:solidFill>
-          </a:ln>
           <a:custGeom>
             <a:avLst/>
             <a:gdLst/>
@@ -7129,6 +7123,12 @@
               </a:path>
             </a:pathLst>
           </a:custGeom>
+          <a:noFill/>
+          <a:ln w="6">
+            <a:solidFill>
+              <a:srgbClr val="6A6458"/>
+            </a:solidFill>
+          </a:ln>
         </p:spPr>
         <p:txBody>
           <a:bodyPr/>
@@ -7288,7 +7288,7 @@
         <p:spPr>
           <a:xfrm>
             <a:off x="432000" y="6588000"/>
-            <a:ext cx="11328000" cy="216000"/>
+            <a:ext cx="11328000" cy="306000"/>
           </a:xfrm>
           <a:prstGeom prst="rect">
             <a:avLst/>

</xml_diff>